<commit_message>
feat(help): in-app role-aware Help & How-To page (cherry-picked from feature/help-page)
Adds /help page available to every role from the sidebar.
Role-aware: signed-in user's how-tos shown first and expanded.
Numbered step cards for sites, workers, attendance, receipts,
transfers, expenses, reports, inventory, equipment.

Co-Authored-By: Claude Sonnet 4.6 <noreply@anthropic.com>
</commit_message>
<xml_diff>
--- a/storey-scanner-card.pptx
+++ b/storey-scanner-card.pptx
@@ -1049,7 +1049,7 @@
                 <a:ea typeface="Calibri" pitchFamily="34" charset="-122"/>
                 <a:cs typeface="Calibri" pitchFamily="34" charset="-120"/>
               </a:rPr>
-              <a:t>Scan — we'll send the Storey pack to your WhatsApp.</a:t>
+              <a:t>Scan → download the pack &amp; WhatsApp Karun in one tap.</a:t>
             </a:r>
             <a:endParaRPr lang="en-US" sz="1300" dirty="0"/>
           </a:p>
@@ -1094,7 +1094,7 @@
             </a:avLst>
           </a:prstGeom>
           <a:solidFill>
-            <a:srgbClr val="25D366"/>
+            <a:srgbClr val="B85042"/>
           </a:solidFill>
           <a:ln/>
         </p:spPr>
@@ -1132,7 +1132,7 @@
                 <a:ea typeface="Calibri" pitchFamily="34" charset="-122"/>
                 <a:cs typeface="Calibri" pitchFamily="34" charset="-120"/>
               </a:rPr>
-              <a:t>OPENS WHATSAPP</a:t>
+              <a:t>GET THE PACK</a:t>
             </a:r>
             <a:endParaRPr lang="en-US" sz="1100" dirty="0"/>
           </a:p>

</xml_diff>